<commit_message>
Ppt is almost done
</commit_message>
<xml_diff>
--- a/Vizsgaremek_Ppt.pptx
+++ b/Vizsgaremek_Ppt.pptx
@@ -13,16 +13,17 @@
     <p:sldId id="274" r:id="rId7"/>
     <p:sldId id="258" r:id="rId8"/>
     <p:sldId id="259" r:id="rId9"/>
-    <p:sldId id="267" r:id="rId10"/>
-    <p:sldId id="260" r:id="rId11"/>
-    <p:sldId id="261" r:id="rId12"/>
-    <p:sldId id="262" r:id="rId13"/>
-    <p:sldId id="268" r:id="rId14"/>
-    <p:sldId id="269" r:id="rId15"/>
-    <p:sldId id="270" r:id="rId16"/>
-    <p:sldId id="271" r:id="rId17"/>
-    <p:sldId id="272" r:id="rId18"/>
-    <p:sldId id="273" r:id="rId19"/>
+    <p:sldId id="275" r:id="rId10"/>
+    <p:sldId id="276" r:id="rId11"/>
+    <p:sldId id="260" r:id="rId12"/>
+    <p:sldId id="261" r:id="rId13"/>
+    <p:sldId id="262" r:id="rId14"/>
+    <p:sldId id="268" r:id="rId15"/>
+    <p:sldId id="269" r:id="rId16"/>
+    <p:sldId id="270" r:id="rId17"/>
+    <p:sldId id="271" r:id="rId18"/>
+    <p:sldId id="272" r:id="rId19"/>
+    <p:sldId id="273" r:id="rId20"/>
   </p:sldIdLst>
   <p:sldSz cx="12192000" cy="6858000"/>
   <p:notesSz cx="6858000" cy="9144000"/>
@@ -284,7 +285,7 @@
           <a:p>
             <a:fld id="{81FACEBD-E6DF-46BC-A87A-292CDFEBE7C7}" type="datetimeFigureOut">
               <a:rPr lang="hu-HU" smtClean="0"/>
-              <a:t>2025. 03. 04.</a:t>
+              <a:t>2025. 03. 31.</a:t>
             </a:fld>
             <a:endParaRPr lang="hu-HU"/>
           </a:p>
@@ -452,7 +453,7 @@
           <a:p>
             <a:fld id="{81FACEBD-E6DF-46BC-A87A-292CDFEBE7C7}" type="datetimeFigureOut">
               <a:rPr lang="hu-HU" smtClean="0"/>
-              <a:t>2025. 03. 04.</a:t>
+              <a:t>2025. 03. 31.</a:t>
             </a:fld>
             <a:endParaRPr lang="hu-HU"/>
           </a:p>
@@ -630,7 +631,7 @@
           <a:p>
             <a:fld id="{81FACEBD-E6DF-46BC-A87A-292CDFEBE7C7}" type="datetimeFigureOut">
               <a:rPr lang="hu-HU" smtClean="0"/>
-              <a:t>2025. 03. 04.</a:t>
+              <a:t>2025. 03. 31.</a:t>
             </a:fld>
             <a:endParaRPr lang="hu-HU"/>
           </a:p>
@@ -798,7 +799,7 @@
           <a:p>
             <a:fld id="{81FACEBD-E6DF-46BC-A87A-292CDFEBE7C7}" type="datetimeFigureOut">
               <a:rPr lang="hu-HU" smtClean="0"/>
-              <a:t>2025. 03. 04.</a:t>
+              <a:t>2025. 03. 31.</a:t>
             </a:fld>
             <a:endParaRPr lang="hu-HU"/>
           </a:p>
@@ -1043,7 +1044,7 @@
           <a:p>
             <a:fld id="{81FACEBD-E6DF-46BC-A87A-292CDFEBE7C7}" type="datetimeFigureOut">
               <a:rPr lang="hu-HU" smtClean="0"/>
-              <a:t>2025. 03. 04.</a:t>
+              <a:t>2025. 03. 31.</a:t>
             </a:fld>
             <a:endParaRPr lang="hu-HU"/>
           </a:p>
@@ -1272,7 +1273,7 @@
           <a:p>
             <a:fld id="{81FACEBD-E6DF-46BC-A87A-292CDFEBE7C7}" type="datetimeFigureOut">
               <a:rPr lang="hu-HU" smtClean="0"/>
-              <a:t>2025. 03. 04.</a:t>
+              <a:t>2025. 03. 31.</a:t>
             </a:fld>
             <a:endParaRPr lang="hu-HU"/>
           </a:p>
@@ -1636,7 +1637,7 @@
           <a:p>
             <a:fld id="{81FACEBD-E6DF-46BC-A87A-292CDFEBE7C7}" type="datetimeFigureOut">
               <a:rPr lang="hu-HU" smtClean="0"/>
-              <a:t>2025. 03. 04.</a:t>
+              <a:t>2025. 03. 31.</a:t>
             </a:fld>
             <a:endParaRPr lang="hu-HU"/>
           </a:p>
@@ -1753,7 +1754,7 @@
           <a:p>
             <a:fld id="{81FACEBD-E6DF-46BC-A87A-292CDFEBE7C7}" type="datetimeFigureOut">
               <a:rPr lang="hu-HU" smtClean="0"/>
-              <a:t>2025. 03. 04.</a:t>
+              <a:t>2025. 03. 31.</a:t>
             </a:fld>
             <a:endParaRPr lang="hu-HU"/>
           </a:p>
@@ -1848,7 +1849,7 @@
           <a:p>
             <a:fld id="{81FACEBD-E6DF-46BC-A87A-292CDFEBE7C7}" type="datetimeFigureOut">
               <a:rPr lang="hu-HU" smtClean="0"/>
-              <a:t>2025. 03. 04.</a:t>
+              <a:t>2025. 03. 31.</a:t>
             </a:fld>
             <a:endParaRPr lang="hu-HU"/>
           </a:p>
@@ -2123,7 +2124,7 @@
           <a:p>
             <a:fld id="{81FACEBD-E6DF-46BC-A87A-292CDFEBE7C7}" type="datetimeFigureOut">
               <a:rPr lang="hu-HU" smtClean="0"/>
-              <a:t>2025. 03. 04.</a:t>
+              <a:t>2025. 03. 31.</a:t>
             </a:fld>
             <a:endParaRPr lang="hu-HU"/>
           </a:p>
@@ -2375,7 +2376,7 @@
           <a:p>
             <a:fld id="{81FACEBD-E6DF-46BC-A87A-292CDFEBE7C7}" type="datetimeFigureOut">
               <a:rPr lang="hu-HU" smtClean="0"/>
-              <a:t>2025. 03. 04.</a:t>
+              <a:t>2025. 03. 31.</a:t>
             </a:fld>
             <a:endParaRPr lang="hu-HU"/>
           </a:p>
@@ -2586,7 +2587,7 @@
           <a:p>
             <a:fld id="{81FACEBD-E6DF-46BC-A87A-292CDFEBE7C7}" type="datetimeFigureOut">
               <a:rPr lang="hu-HU" smtClean="0"/>
-              <a:t>2025. 03. 04.</a:t>
+              <a:t>2025. 03. 31.</a:t>
             </a:fld>
             <a:endParaRPr lang="hu-HU"/>
           </a:p>
@@ -3637,8 +3638,8 @@
         </p:blipFill>
         <p:spPr>
           <a:xfrm>
-            <a:off x="-159446" y="-483467"/>
-            <a:ext cx="5688061" cy="2883658"/>
+            <a:off x="-139337" y="-483467"/>
+            <a:ext cx="4962558" cy="2883658"/>
           </a:xfrm>
           <a:prstGeom prst="rect">
             <a:avLst/>
@@ -3647,20 +3648,14 @@
       </p:pic>
       <p:sp>
         <p:nvSpPr>
-          <p:cNvPr id="3" name="Szövegdoboz 2">
-            <a:extLst>
-              <a:ext uri="{FF2B5EF4-FFF2-40B4-BE49-F238E27FC236}">
-                <a16:creationId xmlns:a16="http://schemas.microsoft.com/office/drawing/2014/main" id="{7D6801A9-2ECA-489E-A0F1-DE717C78513B}"/>
-              </a:ext>
-            </a:extLst>
-          </p:cNvPr>
+          <p:cNvPr id="3" name="Szövegdoboz 2"/>
           <p:cNvSpPr txBox="1"/>
           <p:nvPr/>
         </p:nvSpPr>
         <p:spPr>
           <a:xfrm>
-            <a:off x="337545" y="257851"/>
-            <a:ext cx="3908935" cy="1200329"/>
+            <a:off x="-217714" y="332667"/>
+            <a:ext cx="4206240" cy="1077218"/>
           </a:xfrm>
           <a:prstGeom prst="rect">
             <a:avLst/>
@@ -3673,47 +3668,135 @@
           </a:bodyPr>
           <a:lstStyle/>
           <a:p>
-            <a:r>
-              <a:rPr lang="hu-HU" sz="3600" dirty="0">
+            <a:pPr algn="ctr"/>
+            <a:r>
+              <a:rPr lang="hu-HU" sz="3200" dirty="0" smtClean="0">
                 <a:solidFill>
                   <a:schemeClr val="bg1"/>
                 </a:solidFill>
                 <a:latin typeface="Imprint MT Shadow" panose="04020605060303030202" pitchFamily="82" charset="0"/>
               </a:rPr>
-              <a:t>A Backend kezdetleges kódja</a:t>
-            </a:r>
+              <a:t>Frontend </a:t>
+            </a:r>
+            <a:r>
+              <a:rPr lang="hu-HU" sz="3200" dirty="0" smtClean="0">
+                <a:solidFill>
+                  <a:schemeClr val="bg1"/>
+                </a:solidFill>
+                <a:latin typeface="Imprint MT Shadow" panose="04020605060303030202" pitchFamily="82" charset="0"/>
+              </a:rPr>
+              <a:t>előtte és utána</a:t>
+            </a:r>
+            <a:endParaRPr lang="hu-HU" sz="3200" dirty="0">
+              <a:solidFill>
+                <a:schemeClr val="bg1"/>
+              </a:solidFill>
+              <a:latin typeface="Imprint MT Shadow" panose="04020605060303030202" pitchFamily="82" charset="0"/>
+            </a:endParaRPr>
           </a:p>
         </p:txBody>
       </p:sp>
       <p:pic>
         <p:nvPicPr>
-          <p:cNvPr id="5" name="Kép 4">
-            <a:extLst>
-              <a:ext uri="{FF2B5EF4-FFF2-40B4-BE49-F238E27FC236}">
-                <a16:creationId xmlns:a16="http://schemas.microsoft.com/office/drawing/2014/main" id="{E9B97B08-2971-4994-B1D4-BFE1DA98B1D4}"/>
-              </a:ext>
-            </a:extLst>
-          </p:cNvPr>
+          <p:cNvPr id="12" name="Kép 11"/>
           <p:cNvPicPr>
             <a:picLocks noChangeAspect="1"/>
           </p:cNvPicPr>
           <p:nvPr/>
         </p:nvPicPr>
-        <p:blipFill rotWithShape="1">
+        <p:blipFill>
           <a:blip r:embed="rId4"/>
-          <a:srcRect b="10136"/>
-          <a:stretch/>
+          <a:stretch>
+            <a:fillRect/>
+          </a:stretch>
         </p:blipFill>
         <p:spPr>
-          <a:xfrm>
-            <a:off x="211339" y="2524692"/>
-            <a:ext cx="5852657" cy="2957065"/>
-          </a:xfrm>
-          <a:prstGeom prst="rect">
-            <a:avLst/>
-          </a:prstGeom>
+          <a:xfrm rot="1078552">
+            <a:off x="4995548" y="3814874"/>
+            <a:ext cx="1200053" cy="871833"/>
+          </a:xfrm>
+          <a:prstGeom prst="rect">
+            <a:avLst/>
+          </a:prstGeom>
+        </p:spPr>
+      </p:pic>
+      <p:sp>
+        <p:nvSpPr>
+          <p:cNvPr id="13" name="Jobbra nyíl 12"/>
+          <p:cNvSpPr/>
+          <p:nvPr/>
+        </p:nvSpPr>
+        <p:spPr>
+          <a:xfrm rot="20003168">
+            <a:off x="4952775" y="2986913"/>
+            <a:ext cx="1134382" cy="846700"/>
+          </a:xfrm>
+          <a:prstGeom prst="rightArrow">
+            <a:avLst/>
+          </a:prstGeom>
+        </p:spPr>
+        <p:style>
+          <a:lnRef idx="2">
+            <a:schemeClr val="accent1">
+              <a:shade val="50000"/>
+            </a:schemeClr>
+          </a:lnRef>
+          <a:fillRef idx="1">
+            <a:schemeClr val="accent1"/>
+          </a:fillRef>
+          <a:effectRef idx="0">
+            <a:schemeClr val="accent1"/>
+          </a:effectRef>
+          <a:fontRef idx="minor">
+            <a:schemeClr val="lt1"/>
+          </a:fontRef>
+        </p:style>
+        <p:txBody>
+          <a:bodyPr rtlCol="0" anchor="ctr"/>
+          <a:lstStyle/>
+          <a:p>
+            <a:pPr algn="ctr"/>
+            <a:endParaRPr lang="hu-HU"/>
+          </a:p>
+        </p:txBody>
+      </p:sp>
+      <p:pic>
+        <p:nvPicPr>
+          <p:cNvPr id="5" name="Kép 4"/>
+          <p:cNvPicPr>
+            <a:picLocks noChangeAspect="1"/>
+          </p:cNvPicPr>
+          <p:nvPr/>
+        </p:nvPicPr>
+        <p:blipFill>
+          <a:blip r:embed="rId5" cstate="print">
+            <a:extLst>
+              <a:ext uri="{28A0092B-C50C-407E-A947-70E740481C1C}">
+                <a14:useLocalDpi xmlns:a14="http://schemas.microsoft.com/office/drawing/2010/main" val="0"/>
+              </a:ext>
+            </a:extLst>
+          </a:blip>
+          <a:stretch>
+            <a:fillRect/>
+          </a:stretch>
+        </p:blipFill>
+        <p:spPr>
+          <a:xfrm>
+            <a:off x="294048" y="2732858"/>
+            <a:ext cx="4445041" cy="2494109"/>
+          </a:xfrm>
+          <a:prstGeom prst="rect">
+            <a:avLst/>
+          </a:prstGeom>
+          <a:ln>
+            <a:solidFill>
+              <a:schemeClr val="accent1">
+                <a:lumMod val="50000"/>
+              </a:schemeClr>
+            </a:solidFill>
+          </a:ln>
           <a:effectLst>
-            <a:glow rad="139700">
+            <a:glow rad="63500">
               <a:schemeClr val="accent5">
                 <a:satMod val="175000"/>
                 <a:alpha val="40000"/>
@@ -3725,7 +3808,7 @@
     </p:spTree>
     <p:extLst>
       <p:ext uri="{BB962C8B-B14F-4D97-AF65-F5344CB8AC3E}">
-        <p14:creationId xmlns:p14="http://schemas.microsoft.com/office/powerpoint/2010/main" val="1611349516"/>
+        <p14:creationId xmlns:p14="http://schemas.microsoft.com/office/powerpoint/2010/main" val="1504564082"/>
       </p:ext>
     </p:extLst>
   </p:cSld>
@@ -3818,7 +3901,7 @@
           <p:cNvPr id="3" name="Szövegdoboz 2">
             <a:extLst>
               <a:ext uri="{FF2B5EF4-FFF2-40B4-BE49-F238E27FC236}">
-                <a16:creationId xmlns:a16="http://schemas.microsoft.com/office/drawing/2014/main" id="{7A2003BB-DD81-4263-9D62-44C100A9CB1E}"/>
+                <a16:creationId xmlns:a16="http://schemas.microsoft.com/office/drawing/2014/main" id="{7D6801A9-2ECA-489E-A0F1-DE717C78513B}"/>
               </a:ext>
             </a:extLst>
           </p:cNvPr>
@@ -3827,8 +3910,8 @@
         </p:nvSpPr>
         <p:spPr>
           <a:xfrm>
-            <a:off x="0" y="419753"/>
-            <a:ext cx="3799643" cy="1077218"/>
+            <a:off x="337545" y="257851"/>
+            <a:ext cx="3908935" cy="1200329"/>
           </a:xfrm>
           <a:prstGeom prst="rect">
             <a:avLst/>
@@ -3842,23 +3925,23 @@
           <a:lstStyle/>
           <a:p>
             <a:r>
-              <a:rPr lang="hu-HU" sz="3200" dirty="0">
+              <a:rPr lang="hu-HU" sz="3600" dirty="0">
                 <a:solidFill>
                   <a:schemeClr val="bg1"/>
                 </a:solidFill>
                 <a:latin typeface="Imprint MT Shadow" panose="04020605060303030202" pitchFamily="82" charset="0"/>
               </a:rPr>
-              <a:t>A backend jelenlegi kódja</a:t>
+              <a:t>A Backend kezdetleges kódja</a:t>
             </a:r>
           </a:p>
         </p:txBody>
       </p:sp>
       <p:pic>
         <p:nvPicPr>
-          <p:cNvPr id="6" name="Kép 5">
+          <p:cNvPr id="5" name="Kép 4">
             <a:extLst>
               <a:ext uri="{FF2B5EF4-FFF2-40B4-BE49-F238E27FC236}">
-                <a16:creationId xmlns:a16="http://schemas.microsoft.com/office/drawing/2014/main" id="{76835258-9ED8-44E1-AB14-9FB1C3A15DC5}"/>
+                <a16:creationId xmlns:a16="http://schemas.microsoft.com/office/drawing/2014/main" id="{E9B97B08-2971-4994-B1D4-BFE1DA98B1D4}"/>
               </a:ext>
             </a:extLst>
           </p:cNvPr>
@@ -3869,13 +3952,13 @@
         </p:nvPicPr>
         <p:blipFill rotWithShape="1">
           <a:blip r:embed="rId4"/>
-          <a:srcRect l="1927" r="3723"/>
+          <a:srcRect b="10136"/>
           <a:stretch/>
         </p:blipFill>
         <p:spPr>
           <a:xfrm>
-            <a:off x="322218" y="2400191"/>
-            <a:ext cx="6679474" cy="3248426"/>
+            <a:off x="211339" y="2524692"/>
+            <a:ext cx="5852657" cy="2957065"/>
           </a:xfrm>
           <a:prstGeom prst="rect">
             <a:avLst/>
@@ -3890,62 +3973,10 @@
           </a:effectLst>
         </p:spPr>
       </p:pic>
-      <p:sp>
-        <p:nvSpPr>
-          <p:cNvPr id="5" name="Szövegdoboz 4"/>
-          <p:cNvSpPr txBox="1"/>
-          <p:nvPr/>
-        </p:nvSpPr>
-        <p:spPr>
-          <a:xfrm>
-            <a:off x="7916091" y="2654481"/>
-            <a:ext cx="3091543" cy="2554545"/>
-          </a:xfrm>
-          <a:prstGeom prst="rect">
-            <a:avLst/>
-          </a:prstGeom>
-          <a:noFill/>
-          <a:ln>
-            <a:solidFill>
-              <a:srgbClr val="302F34"/>
-            </a:solidFill>
-          </a:ln>
-          <a:effectLst>
-            <a:glow rad="101600">
-              <a:srgbClr val="302F34">
-                <a:alpha val="60000"/>
-              </a:srgbClr>
-            </a:glow>
-          </a:effectLst>
-        </p:spPr>
-        <p:txBody>
-          <a:bodyPr wrap="square" rtlCol="0">
-            <a:spAutoFit/>
-          </a:bodyPr>
-          <a:lstStyle/>
-          <a:p>
-            <a:r>
-              <a:rPr lang="hu-HU" sz="3200" dirty="0" smtClean="0">
-                <a:solidFill>
-                  <a:schemeClr val="bg1"/>
-                </a:solidFill>
-                <a:latin typeface="Imprint MT Shadow" panose="04020605060303030202" pitchFamily="82" charset="0"/>
-              </a:rPr>
-              <a:t>Itt a Backendbe az általunk 5 nagyon fontos végpontok találhatóak meg</a:t>
-            </a:r>
-            <a:endParaRPr lang="hu-HU" sz="3200" dirty="0">
-              <a:solidFill>
-                <a:schemeClr val="bg1"/>
-              </a:solidFill>
-              <a:latin typeface="Imprint MT Shadow" panose="04020605060303030202" pitchFamily="82" charset="0"/>
-            </a:endParaRPr>
-          </a:p>
-        </p:txBody>
-      </p:sp>
     </p:spTree>
     <p:extLst>
       <p:ext uri="{BB962C8B-B14F-4D97-AF65-F5344CB8AC3E}">
-        <p14:creationId xmlns:p14="http://schemas.microsoft.com/office/powerpoint/2010/main" val="837542327"/>
+        <p14:creationId xmlns:p14="http://schemas.microsoft.com/office/powerpoint/2010/main" val="1611349516"/>
       </p:ext>
     </p:extLst>
   </p:cSld>
@@ -4017,27 +4048,68 @@
           </p:cNvPicPr>
           <p:nvPr/>
         </p:nvPicPr>
-        <p:blipFill rotWithShape="1">
+        <p:blipFill>
           <a:blip r:embed="rId3"/>
-          <a:srcRect l="12683"/>
-          <a:stretch/>
+          <a:stretch>
+            <a:fillRect/>
+          </a:stretch>
         </p:blipFill>
         <p:spPr>
           <a:xfrm>
-            <a:off x="-64008" y="-473942"/>
-            <a:ext cx="4966640" cy="2883658"/>
+            <a:off x="-159446" y="-483467"/>
+            <a:ext cx="5688061" cy="2883658"/>
           </a:xfrm>
           <a:prstGeom prst="rect">
             <a:avLst/>
           </a:prstGeom>
         </p:spPr>
       </p:pic>
+      <p:sp>
+        <p:nvSpPr>
+          <p:cNvPr id="3" name="Szövegdoboz 2">
+            <a:extLst>
+              <a:ext uri="{FF2B5EF4-FFF2-40B4-BE49-F238E27FC236}">
+                <a16:creationId xmlns:a16="http://schemas.microsoft.com/office/drawing/2014/main" id="{7A2003BB-DD81-4263-9D62-44C100A9CB1E}"/>
+              </a:ext>
+            </a:extLst>
+          </p:cNvPr>
+          <p:cNvSpPr txBox="1"/>
+          <p:nvPr/>
+        </p:nvSpPr>
+        <p:spPr>
+          <a:xfrm>
+            <a:off x="0" y="419753"/>
+            <a:ext cx="3799643" cy="1077218"/>
+          </a:xfrm>
+          <a:prstGeom prst="rect">
+            <a:avLst/>
+          </a:prstGeom>
+          <a:noFill/>
+        </p:spPr>
+        <p:txBody>
+          <a:bodyPr wrap="square" rtlCol="0">
+            <a:spAutoFit/>
+          </a:bodyPr>
+          <a:lstStyle/>
+          <a:p>
+            <a:r>
+              <a:rPr lang="hu-HU" sz="3200" dirty="0">
+                <a:solidFill>
+                  <a:schemeClr val="bg1"/>
+                </a:solidFill>
+                <a:latin typeface="Imprint MT Shadow" panose="04020605060303030202" pitchFamily="82" charset="0"/>
+              </a:rPr>
+              <a:t>A backend jelenlegi kódja</a:t>
+            </a:r>
+          </a:p>
+        </p:txBody>
+      </p:sp>
       <p:pic>
         <p:nvPicPr>
-          <p:cNvPr id="3" name="Kép 2">
+          <p:cNvPr id="6" name="Kép 5">
             <a:extLst>
               <a:ext uri="{FF2B5EF4-FFF2-40B4-BE49-F238E27FC236}">
-                <a16:creationId xmlns:a16="http://schemas.microsoft.com/office/drawing/2014/main" id="{DEE65220-3BBA-454A-B2B5-73C36617ED17}"/>
+                <a16:creationId xmlns:a16="http://schemas.microsoft.com/office/drawing/2014/main" id="{76835258-9ED8-44E1-AB14-9FB1C3A15DC5}"/>
               </a:ext>
             </a:extLst>
           </p:cNvPr>
@@ -4046,16 +4118,15 @@
           </p:cNvPicPr>
           <p:nvPr/>
         </p:nvPicPr>
-        <p:blipFill>
+        <p:blipFill rotWithShape="1">
           <a:blip r:embed="rId4"/>
-          <a:stretch>
-            <a:fillRect/>
-          </a:stretch>
+          <a:srcRect l="1927" r="3723"/>
+          <a:stretch/>
         </p:blipFill>
         <p:spPr>
           <a:xfrm>
-            <a:off x="270509" y="2203180"/>
-            <a:ext cx="8724911" cy="2225945"/>
+            <a:off x="322218" y="2400191"/>
+            <a:ext cx="6679474" cy="3248426"/>
           </a:xfrm>
           <a:prstGeom prst="rect">
             <a:avLst/>
@@ -4072,25 +4143,31 @@
       </p:pic>
       <p:sp>
         <p:nvSpPr>
-          <p:cNvPr id="5" name="Szövegdoboz 4">
-            <a:extLst>
-              <a:ext uri="{FF2B5EF4-FFF2-40B4-BE49-F238E27FC236}">
-                <a16:creationId xmlns:a16="http://schemas.microsoft.com/office/drawing/2014/main" id="{53B52D56-9B8A-4215-86C5-B04868F5824B}"/>
-              </a:ext>
-            </a:extLst>
-          </p:cNvPr>
+          <p:cNvPr id="5" name="Szövegdoboz 4"/>
           <p:cNvSpPr txBox="1"/>
           <p:nvPr/>
         </p:nvSpPr>
         <p:spPr>
           <a:xfrm>
-            <a:off x="0" y="286756"/>
-            <a:ext cx="4174369" cy="1077218"/>
+            <a:off x="7916091" y="2654481"/>
+            <a:ext cx="3091543" cy="2554545"/>
           </a:xfrm>
           <a:prstGeom prst="rect">
             <a:avLst/>
           </a:prstGeom>
           <a:noFill/>
+          <a:ln>
+            <a:solidFill>
+              <a:srgbClr val="302F34"/>
+            </a:solidFill>
+          </a:ln>
+          <a:effectLst>
+            <a:glow rad="101600">
+              <a:srgbClr val="302F34">
+                <a:alpha val="60000"/>
+              </a:srgbClr>
+            </a:glow>
+          </a:effectLst>
         </p:spPr>
         <p:txBody>
           <a:bodyPr wrap="square" rtlCol="0">
@@ -4105,25 +4182,7 @@
                 </a:solidFill>
                 <a:latin typeface="Imprint MT Shadow" panose="04020605060303030202" pitchFamily="82" charset="0"/>
               </a:rPr>
-              <a:t>Az adatbázis </a:t>
-            </a:r>
-            <a:r>
-              <a:rPr lang="hu-HU" sz="3200" dirty="0">
-                <a:solidFill>
-                  <a:schemeClr val="bg1"/>
-                </a:solidFill>
-                <a:latin typeface="Imprint MT Shadow" panose="04020605060303030202" pitchFamily="82" charset="0"/>
-              </a:rPr>
-              <a:t>jelenlegi </a:t>
-            </a:r>
-            <a:r>
-              <a:rPr lang="hu-HU" sz="3200" dirty="0" smtClean="0">
-                <a:solidFill>
-                  <a:schemeClr val="bg1"/>
-                </a:solidFill>
-                <a:latin typeface="Imprint MT Shadow" panose="04020605060303030202" pitchFamily="82" charset="0"/>
-              </a:rPr>
-              <a:t>	állapota</a:t>
+              <a:t>Itt a Backendbe az általunk 5 nagyon fontos végpontok találhatóak meg</a:t>
             </a:r>
             <a:endParaRPr lang="hu-HU" sz="3200" dirty="0">
               <a:solidFill>
@@ -4137,7 +4196,7 @@
     </p:spTree>
     <p:extLst>
       <p:ext uri="{BB962C8B-B14F-4D97-AF65-F5344CB8AC3E}">
-        <p14:creationId xmlns:p14="http://schemas.microsoft.com/office/powerpoint/2010/main" val="3910775159"/>
+        <p14:creationId xmlns:p14="http://schemas.microsoft.com/office/powerpoint/2010/main" val="837542327"/>
       </p:ext>
     </p:extLst>
   </p:cSld>
@@ -4209,26 +4268,127 @@
           </p:cNvPicPr>
           <p:nvPr/>
         </p:nvPicPr>
+        <p:blipFill rotWithShape="1">
+          <a:blip r:embed="rId3"/>
+          <a:srcRect l="12683"/>
+          <a:stretch/>
+        </p:blipFill>
+        <p:spPr>
+          <a:xfrm>
+            <a:off x="-64008" y="-473942"/>
+            <a:ext cx="4966640" cy="2883658"/>
+          </a:xfrm>
+          <a:prstGeom prst="rect">
+            <a:avLst/>
+          </a:prstGeom>
+        </p:spPr>
+      </p:pic>
+      <p:pic>
+        <p:nvPicPr>
+          <p:cNvPr id="3" name="Kép 2">
+            <a:extLst>
+              <a:ext uri="{FF2B5EF4-FFF2-40B4-BE49-F238E27FC236}">
+                <a16:creationId xmlns:a16="http://schemas.microsoft.com/office/drawing/2014/main" id="{DEE65220-3BBA-454A-B2B5-73C36617ED17}"/>
+              </a:ext>
+            </a:extLst>
+          </p:cNvPr>
+          <p:cNvPicPr>
+            <a:picLocks noChangeAspect="1"/>
+          </p:cNvPicPr>
+          <p:nvPr/>
+        </p:nvPicPr>
         <p:blipFill>
-          <a:blip r:embed="rId3"/>
+          <a:blip r:embed="rId4"/>
           <a:stretch>
             <a:fillRect/>
           </a:stretch>
         </p:blipFill>
         <p:spPr>
           <a:xfrm>
-            <a:off x="-159446" y="-483467"/>
-            <a:ext cx="5688061" cy="2883658"/>
-          </a:xfrm>
-          <a:prstGeom prst="rect">
-            <a:avLst/>
-          </a:prstGeom>
+            <a:off x="270509" y="2203180"/>
+            <a:ext cx="8724911" cy="2225945"/>
+          </a:xfrm>
+          <a:prstGeom prst="rect">
+            <a:avLst/>
+          </a:prstGeom>
+          <a:effectLst>
+            <a:glow rad="139700">
+              <a:schemeClr val="accent5">
+                <a:satMod val="175000"/>
+                <a:alpha val="40000"/>
+              </a:schemeClr>
+            </a:glow>
+          </a:effectLst>
         </p:spPr>
       </p:pic>
+      <p:sp>
+        <p:nvSpPr>
+          <p:cNvPr id="5" name="Szövegdoboz 4">
+            <a:extLst>
+              <a:ext uri="{FF2B5EF4-FFF2-40B4-BE49-F238E27FC236}">
+                <a16:creationId xmlns:a16="http://schemas.microsoft.com/office/drawing/2014/main" id="{53B52D56-9B8A-4215-86C5-B04868F5824B}"/>
+              </a:ext>
+            </a:extLst>
+          </p:cNvPr>
+          <p:cNvSpPr txBox="1"/>
+          <p:nvPr/>
+        </p:nvSpPr>
+        <p:spPr>
+          <a:xfrm>
+            <a:off x="0" y="286756"/>
+            <a:ext cx="4174369" cy="1077218"/>
+          </a:xfrm>
+          <a:prstGeom prst="rect">
+            <a:avLst/>
+          </a:prstGeom>
+          <a:noFill/>
+        </p:spPr>
+        <p:txBody>
+          <a:bodyPr wrap="square" rtlCol="0">
+            <a:spAutoFit/>
+          </a:bodyPr>
+          <a:lstStyle/>
+          <a:p>
+            <a:r>
+              <a:rPr lang="hu-HU" sz="3200" dirty="0" smtClean="0">
+                <a:solidFill>
+                  <a:schemeClr val="bg1"/>
+                </a:solidFill>
+                <a:latin typeface="Imprint MT Shadow" panose="04020605060303030202" pitchFamily="82" charset="0"/>
+              </a:rPr>
+              <a:t>Az adatbázis </a:t>
+            </a:r>
+            <a:r>
+              <a:rPr lang="hu-HU" sz="3200" dirty="0">
+                <a:solidFill>
+                  <a:schemeClr val="bg1"/>
+                </a:solidFill>
+                <a:latin typeface="Imprint MT Shadow" panose="04020605060303030202" pitchFamily="82" charset="0"/>
+              </a:rPr>
+              <a:t>jelenlegi </a:t>
+            </a:r>
+            <a:r>
+              <a:rPr lang="hu-HU" sz="3200" dirty="0" smtClean="0">
+                <a:solidFill>
+                  <a:schemeClr val="bg1"/>
+                </a:solidFill>
+                <a:latin typeface="Imprint MT Shadow" panose="04020605060303030202" pitchFamily="82" charset="0"/>
+              </a:rPr>
+              <a:t>	állapota</a:t>
+            </a:r>
+            <a:endParaRPr lang="hu-HU" sz="3200" dirty="0">
+              <a:solidFill>
+                <a:schemeClr val="bg1"/>
+              </a:solidFill>
+              <a:latin typeface="Imprint MT Shadow" panose="04020605060303030202" pitchFamily="82" charset="0"/>
+            </a:endParaRPr>
+          </a:p>
+        </p:txBody>
+      </p:sp>
     </p:spTree>
     <p:extLst>
       <p:ext uri="{BB962C8B-B14F-4D97-AF65-F5344CB8AC3E}">
-        <p14:creationId xmlns:p14="http://schemas.microsoft.com/office/powerpoint/2010/main" val="3793741577"/>
+        <p14:creationId xmlns:p14="http://schemas.microsoft.com/office/powerpoint/2010/main" val="3910775159"/>
       </p:ext>
     </p:extLst>
   </p:cSld>
@@ -4319,7 +4479,7 @@
     </p:spTree>
     <p:extLst>
       <p:ext uri="{BB962C8B-B14F-4D97-AF65-F5344CB8AC3E}">
-        <p14:creationId xmlns:p14="http://schemas.microsoft.com/office/powerpoint/2010/main" val="3270997015"/>
+        <p14:creationId xmlns:p14="http://schemas.microsoft.com/office/powerpoint/2010/main" val="3793741577"/>
       </p:ext>
     </p:extLst>
   </p:cSld>
@@ -4410,7 +4570,7 @@
     </p:spTree>
     <p:extLst>
       <p:ext uri="{BB962C8B-B14F-4D97-AF65-F5344CB8AC3E}">
-        <p14:creationId xmlns:p14="http://schemas.microsoft.com/office/powerpoint/2010/main" val="2504730819"/>
+        <p14:creationId xmlns:p14="http://schemas.microsoft.com/office/powerpoint/2010/main" val="3270997015"/>
       </p:ext>
     </p:extLst>
   </p:cSld>
@@ -4501,7 +4661,7 @@
     </p:spTree>
     <p:extLst>
       <p:ext uri="{BB962C8B-B14F-4D97-AF65-F5344CB8AC3E}">
-        <p14:creationId xmlns:p14="http://schemas.microsoft.com/office/powerpoint/2010/main" val="1335619839"/>
+        <p14:creationId xmlns:p14="http://schemas.microsoft.com/office/powerpoint/2010/main" val="2504730819"/>
       </p:ext>
     </p:extLst>
   </p:cSld>
@@ -4592,7 +4752,7 @@
     </p:spTree>
     <p:extLst>
       <p:ext uri="{BB962C8B-B14F-4D97-AF65-F5344CB8AC3E}">
-        <p14:creationId xmlns:p14="http://schemas.microsoft.com/office/powerpoint/2010/main" val="1037378568"/>
+        <p14:creationId xmlns:p14="http://schemas.microsoft.com/office/powerpoint/2010/main" val="1335619839"/>
       </p:ext>
     </p:extLst>
   </p:cSld>
@@ -4656,6 +4816,97 @@
           </a:prstGeom>
         </p:spPr>
       </p:pic>
+      <p:pic>
+        <p:nvPicPr>
+          <p:cNvPr id="2" name="Kép 1"/>
+          <p:cNvPicPr>
+            <a:picLocks noChangeAspect="1"/>
+          </p:cNvPicPr>
+          <p:nvPr/>
+        </p:nvPicPr>
+        <p:blipFill>
+          <a:blip r:embed="rId3"/>
+          <a:stretch>
+            <a:fillRect/>
+          </a:stretch>
+        </p:blipFill>
+        <p:spPr>
+          <a:xfrm>
+            <a:off x="-159446" y="-483467"/>
+            <a:ext cx="5688061" cy="2883658"/>
+          </a:xfrm>
+          <a:prstGeom prst="rect">
+            <a:avLst/>
+          </a:prstGeom>
+        </p:spPr>
+      </p:pic>
+    </p:spTree>
+    <p:extLst>
+      <p:ext uri="{BB962C8B-B14F-4D97-AF65-F5344CB8AC3E}">
+        <p14:creationId xmlns:p14="http://schemas.microsoft.com/office/powerpoint/2010/main" val="1037378568"/>
+      </p:ext>
+    </p:extLst>
+  </p:cSld>
+  <p:clrMapOvr>
+    <a:masterClrMapping/>
+  </p:clrMapOvr>
+  <p:timing>
+    <p:tnLst>
+      <p:par>
+        <p:cTn id="1" dur="indefinite" restart="never" nodeType="tmRoot"/>
+      </p:par>
+    </p:tnLst>
+  </p:timing>
+</p:sld>
+</file>
+
+<file path=ppt/slides/slide19.xml><?xml version="1.0" encoding="utf-8"?>
+<p:sld xmlns:a="http://schemas.openxmlformats.org/drawingml/2006/main" xmlns:r="http://schemas.openxmlformats.org/officeDocument/2006/relationships" xmlns:p="http://schemas.openxmlformats.org/presentationml/2006/main">
+  <p:cSld>
+    <p:spTree>
+      <p:nvGrpSpPr>
+        <p:cNvPr id="1" name=""/>
+        <p:cNvGrpSpPr/>
+        <p:nvPr/>
+      </p:nvGrpSpPr>
+      <p:grpSpPr>
+        <a:xfrm>
+          <a:off x="0" y="0"/>
+          <a:ext cx="0" cy="0"/>
+          <a:chOff x="0" y="0"/>
+          <a:chExt cx="0" cy="0"/>
+        </a:xfrm>
+      </p:grpSpPr>
+      <p:pic>
+        <p:nvPicPr>
+          <p:cNvPr id="4" name="Kép 3"/>
+          <p:cNvPicPr>
+            <a:picLocks noChangeAspect="1"/>
+          </p:cNvPicPr>
+          <p:nvPr/>
+        </p:nvPicPr>
+        <p:blipFill>
+          <a:blip r:embed="rId2">
+            <a:extLst>
+              <a:ext uri="{28A0092B-C50C-407E-A947-70E740481C1C}">
+                <a14:useLocalDpi xmlns:a14="http://schemas.microsoft.com/office/drawing/2010/main" val="0"/>
+              </a:ext>
+            </a:extLst>
+          </a:blip>
+          <a:stretch>
+            <a:fillRect/>
+          </a:stretch>
+        </p:blipFill>
+        <p:spPr>
+          <a:xfrm>
+            <a:off x="-64008" y="0"/>
+            <a:ext cx="12256008" cy="6858000"/>
+          </a:xfrm>
+          <a:prstGeom prst="rect">
+            <a:avLst/>
+          </a:prstGeom>
+        </p:spPr>
+      </p:pic>
       <p:sp>
         <p:nvSpPr>
           <p:cNvPr id="3" name="Szövegdoboz 2"/>
@@ -4706,13 +4957,13 @@
   <p:clrMapOvr>
     <a:masterClrMapping/>
   </p:clrMapOvr>
-  <mc:AlternateContent xmlns:mc="http://schemas.openxmlformats.org/markup-compatibility/2006">
-    <mc:Choice xmlns:p14="http://schemas.microsoft.com/office/powerpoint/2010/main" Requires="p14">
+  <mc:AlternateContent xmlns:mc="http://schemas.openxmlformats.org/markup-compatibility/2006" xmlns:p14="http://schemas.microsoft.com/office/powerpoint/2010/main">
+    <mc:Choice Requires="p14">
       <p:transition spd="slow" p14:dur="1300">
         <p14:pan dir="u"/>
       </p:transition>
     </mc:Choice>
-    <mc:Fallback>
+    <mc:Fallback xmlns="">
       <p:transition spd="slow">
         <p:fade/>
       </p:transition>
@@ -5574,16 +5825,7 @@
                 </a:solidFill>
                 <a:latin typeface="Imprint MT Shadow" panose="04020605060303030202" pitchFamily="82" charset="0"/>
               </a:rPr>
-              <a:t>található a GitHub-ba </a:t>
-            </a:r>
-            <a:r>
-              <a:rPr lang="hu-HU" sz="3200" dirty="0" smtClean="0">
-                <a:solidFill>
-                  <a:schemeClr val="bg1"/>
-                </a:solidFill>
-                <a:latin typeface="Imprint MT Shadow" panose="04020605060303030202" pitchFamily="82" charset="0"/>
-              </a:rPr>
-              <a:t>ebből mi </a:t>
+              <a:t>található a GitHub-ba ebből mi </a:t>
             </a:r>
             <a:r>
               <a:rPr lang="hu-HU" sz="3200" dirty="0">
@@ -5838,43 +6080,7 @@
                 </a:solidFill>
                 <a:latin typeface="Imprint MT Shadow" panose="04020605060303030202" pitchFamily="82" charset="0"/>
               </a:rPr>
-              <a:t>A </a:t>
-            </a:r>
-            <a:r>
-              <a:rPr lang="hu-HU" sz="2800" dirty="0" smtClean="0">
-                <a:solidFill>
-                  <a:schemeClr val="bg1"/>
-                </a:solidFill>
-                <a:latin typeface="Imprint MT Shadow" panose="04020605060303030202" pitchFamily="82" charset="0"/>
-              </a:rPr>
-              <a:t>Frontendbe </a:t>
-            </a:r>
-            <a:r>
-              <a:rPr lang="hu-HU" sz="2800" dirty="0" smtClean="0">
-                <a:solidFill>
-                  <a:schemeClr val="bg1"/>
-                </a:solidFill>
-                <a:latin typeface="Imprint MT Shadow" panose="04020605060303030202" pitchFamily="82" charset="0"/>
-              </a:rPr>
-              <a:t>a </a:t>
-            </a:r>
-            <a:r>
-              <a:rPr lang="hu-HU" sz="2800" dirty="0" smtClean="0">
-                <a:solidFill>
-                  <a:schemeClr val="bg1"/>
-                </a:solidFill>
-                <a:latin typeface="Imprint MT Shadow" panose="04020605060303030202" pitchFamily="82" charset="0"/>
-              </a:rPr>
-              <a:t>Backendbe és az Adatbázisban </a:t>
-            </a:r>
-            <a:r>
-              <a:rPr lang="hu-HU" sz="2800" dirty="0" smtClean="0">
-                <a:solidFill>
-                  <a:schemeClr val="bg1"/>
-                </a:solidFill>
-                <a:latin typeface="Imprint MT Shadow" panose="04020605060303030202" pitchFamily="82" charset="0"/>
-              </a:rPr>
-              <a:t>dolgozunk a legtöbbet itt találhatóak a legtöbb commitok is.</a:t>
+              <a:t>A Frontendbe a Backendbe és az Adatbázisban dolgozunk a legtöbbet itt találhatóak a legtöbb commitok is.</a:t>
             </a:r>
             <a:endParaRPr lang="hu-HU" sz="2800" dirty="0">
               <a:solidFill>
@@ -7230,7 +7436,16 @@
                 </a:solidFill>
                 <a:latin typeface="Imprint MT Shadow" panose="04020605060303030202" pitchFamily="82" charset="0"/>
               </a:rPr>
-              <a:t>Frontend jelenlegi kinézete</a:t>
+              <a:t>Frontend </a:t>
+            </a:r>
+            <a:r>
+              <a:rPr lang="hu-HU" sz="3200" dirty="0" smtClean="0">
+                <a:solidFill>
+                  <a:schemeClr val="bg1"/>
+                </a:solidFill>
+                <a:latin typeface="Imprint MT Shadow" panose="04020605060303030202" pitchFamily="82" charset="0"/>
+              </a:rPr>
+              <a:t>előtte és utána</a:t>
             </a:r>
             <a:endParaRPr lang="hu-HU" sz="3200" dirty="0">
               <a:solidFill>
@@ -7241,6 +7456,160 @@
           </a:p>
         </p:txBody>
       </p:sp>
+      <p:pic>
+        <p:nvPicPr>
+          <p:cNvPr id="8" name="Kép 7"/>
+          <p:cNvPicPr>
+            <a:picLocks noChangeAspect="1"/>
+          </p:cNvPicPr>
+          <p:nvPr/>
+        </p:nvPicPr>
+        <p:blipFill>
+          <a:blip r:embed="rId4" cstate="print">
+            <a:extLst>
+              <a:ext uri="{28A0092B-C50C-407E-A947-70E740481C1C}">
+                <a14:useLocalDpi xmlns:a14="http://schemas.microsoft.com/office/drawing/2010/main" val="0"/>
+              </a:ext>
+            </a:extLst>
+          </a:blip>
+          <a:stretch>
+            <a:fillRect/>
+          </a:stretch>
+        </p:blipFill>
+        <p:spPr>
+          <a:xfrm>
+            <a:off x="482242" y="2056061"/>
+            <a:ext cx="3884934" cy="2152387"/>
+          </a:xfrm>
+          <a:prstGeom prst="rect">
+            <a:avLst/>
+          </a:prstGeom>
+          <a:ln>
+            <a:solidFill>
+              <a:schemeClr val="accent1">
+                <a:lumMod val="50000"/>
+              </a:schemeClr>
+            </a:solidFill>
+          </a:ln>
+          <a:effectLst>
+            <a:glow rad="63500">
+              <a:schemeClr val="accent5">
+                <a:satMod val="175000"/>
+                <a:alpha val="40000"/>
+              </a:schemeClr>
+            </a:glow>
+          </a:effectLst>
+        </p:spPr>
+      </p:pic>
+      <p:pic>
+        <p:nvPicPr>
+          <p:cNvPr id="5" name="Kép 4"/>
+          <p:cNvPicPr>
+            <a:picLocks noChangeAspect="1"/>
+          </p:cNvPicPr>
+          <p:nvPr/>
+        </p:nvPicPr>
+        <p:blipFill>
+          <a:blip r:embed="rId5" cstate="print">
+            <a:extLst>
+              <a:ext uri="{28A0092B-C50C-407E-A947-70E740481C1C}">
+                <a14:useLocalDpi xmlns:a14="http://schemas.microsoft.com/office/drawing/2010/main" val="0"/>
+              </a:ext>
+            </a:extLst>
+          </a:blip>
+          <a:stretch>
+            <a:fillRect/>
+          </a:stretch>
+        </p:blipFill>
+        <p:spPr>
+          <a:xfrm>
+            <a:off x="482242" y="4456252"/>
+            <a:ext cx="3884934" cy="2174887"/>
+          </a:xfrm>
+          <a:prstGeom prst="rect">
+            <a:avLst/>
+          </a:prstGeom>
+          <a:ln>
+            <a:solidFill>
+              <a:schemeClr val="accent1">
+                <a:lumMod val="50000"/>
+              </a:schemeClr>
+            </a:solidFill>
+          </a:ln>
+          <a:effectLst>
+            <a:glow rad="63500">
+              <a:schemeClr val="accent5">
+                <a:satMod val="175000"/>
+                <a:alpha val="40000"/>
+              </a:schemeClr>
+            </a:glow>
+          </a:effectLst>
+        </p:spPr>
+      </p:pic>
+      <p:sp>
+        <p:nvSpPr>
+          <p:cNvPr id="6" name="Jobbra nyíl 5"/>
+          <p:cNvSpPr/>
+          <p:nvPr/>
+        </p:nvSpPr>
+        <p:spPr>
+          <a:xfrm>
+            <a:off x="4823221" y="2558685"/>
+            <a:ext cx="1408997" cy="1003119"/>
+          </a:xfrm>
+          <a:prstGeom prst="rightArrow">
+            <a:avLst/>
+          </a:prstGeom>
+        </p:spPr>
+        <p:style>
+          <a:lnRef idx="2">
+            <a:schemeClr val="accent1">
+              <a:shade val="50000"/>
+            </a:schemeClr>
+          </a:lnRef>
+          <a:fillRef idx="1">
+            <a:schemeClr val="accent1"/>
+          </a:fillRef>
+          <a:effectRef idx="0">
+            <a:schemeClr val="accent1"/>
+          </a:effectRef>
+          <a:fontRef idx="minor">
+            <a:schemeClr val="lt1"/>
+          </a:fontRef>
+        </p:style>
+        <p:txBody>
+          <a:bodyPr rtlCol="0" anchor="ctr"/>
+          <a:lstStyle/>
+          <a:p>
+            <a:pPr algn="ctr"/>
+            <a:endParaRPr lang="hu-HU"/>
+          </a:p>
+        </p:txBody>
+      </p:sp>
+      <p:pic>
+        <p:nvPicPr>
+          <p:cNvPr id="7" name="Kép 6"/>
+          <p:cNvPicPr>
+            <a:picLocks noChangeAspect="1"/>
+          </p:cNvPicPr>
+          <p:nvPr/>
+        </p:nvPicPr>
+        <p:blipFill>
+          <a:blip r:embed="rId6"/>
+          <a:stretch>
+            <a:fillRect/>
+          </a:stretch>
+        </p:blipFill>
+        <p:spPr>
+          <a:xfrm>
+            <a:off x="4805630" y="5084079"/>
+            <a:ext cx="1426588" cy="1036410"/>
+          </a:xfrm>
+          <a:prstGeom prst="rect">
+            <a:avLst/>
+          </a:prstGeom>
+        </p:spPr>
+      </p:pic>
     </p:spTree>
     <p:extLst>
       <p:ext uri="{BB962C8B-B14F-4D97-AF65-F5344CB8AC3E}">
@@ -7316,15 +7685,16 @@
           </p:cNvPicPr>
           <p:nvPr/>
         </p:nvPicPr>
-        <p:blipFill rotWithShape="1">
+        <p:blipFill>
           <a:blip r:embed="rId3"/>
-          <a:srcRect l="13520"/>
-          <a:stretch/>
+          <a:stretch>
+            <a:fillRect/>
+          </a:stretch>
         </p:blipFill>
         <p:spPr>
           <a:xfrm>
-            <a:off x="-64008" y="-521567"/>
-            <a:ext cx="4919015" cy="2883658"/>
+            <a:off x="-139337" y="-483467"/>
+            <a:ext cx="4962558" cy="2883658"/>
           </a:xfrm>
           <a:prstGeom prst="rect">
             <a:avLst/>
@@ -7339,8 +7709,8 @@
         </p:nvSpPr>
         <p:spPr>
           <a:xfrm>
-            <a:off x="0" y="266700"/>
-            <a:ext cx="3686175" cy="1077218"/>
+            <a:off x="-217714" y="332667"/>
+            <a:ext cx="4206240" cy="1077218"/>
           </a:xfrm>
           <a:prstGeom prst="rect">
             <a:avLst/>
@@ -7361,7 +7731,16 @@
                 </a:solidFill>
                 <a:latin typeface="Imprint MT Shadow" panose="04020605060303030202" pitchFamily="82" charset="0"/>
               </a:rPr>
-              <a:t>Utolsó simítások a Frontendbe</a:t>
+              <a:t>Frontend </a:t>
+            </a:r>
+            <a:r>
+              <a:rPr lang="hu-HU" sz="3200" dirty="0" smtClean="0">
+                <a:solidFill>
+                  <a:schemeClr val="bg1"/>
+                </a:solidFill>
+                <a:latin typeface="Imprint MT Shadow" panose="04020605060303030202" pitchFamily="82" charset="0"/>
+              </a:rPr>
+              <a:t>előtte és utána</a:t>
             </a:r>
             <a:endParaRPr lang="hu-HU" sz="3200" dirty="0">
               <a:solidFill>
@@ -7374,48 +7753,226 @@
       </p:sp>
       <p:sp>
         <p:nvSpPr>
-          <p:cNvPr id="5" name="Szövegdoboz 4"/>
-          <p:cNvSpPr txBox="1"/>
-          <p:nvPr/>
-        </p:nvSpPr>
-        <p:spPr>
-          <a:xfrm>
-            <a:off x="247650" y="2104916"/>
-            <a:ext cx="4943475" cy="1754326"/>
-          </a:xfrm>
-          <a:prstGeom prst="rect">
-            <a:avLst/>
-          </a:prstGeom>
-          <a:noFill/>
-        </p:spPr>
-        <p:txBody>
-          <a:bodyPr wrap="square" rtlCol="0">
-            <a:spAutoFit/>
-          </a:bodyPr>
-          <a:lstStyle/>
-          <a:p>
-            <a:r>
-              <a:rPr lang="hu-HU" sz="3600" dirty="0" smtClean="0">
-                <a:solidFill>
-                  <a:schemeClr val="bg1"/>
-                </a:solidFill>
-                <a:latin typeface="Imprint MT Shadow" panose="04020605060303030202" pitchFamily="82" charset="0"/>
-              </a:rPr>
-              <a:t>Bejelentkezés, Regisztráció, Profil és Kommentek kinézete</a:t>
-            </a:r>
-            <a:endParaRPr lang="hu-HU" sz="3600" dirty="0">
-              <a:solidFill>
-                <a:schemeClr val="bg1"/>
-              </a:solidFill>
-              <a:latin typeface="Imprint MT Shadow" panose="04020605060303030202" pitchFamily="82" charset="0"/>
-            </a:endParaRPr>
+          <p:cNvPr id="6" name="Jobbra nyíl 5"/>
+          <p:cNvSpPr/>
+          <p:nvPr/>
+        </p:nvSpPr>
+        <p:spPr>
+          <a:xfrm rot="19674300">
+            <a:off x="4180911" y="2467964"/>
+            <a:ext cx="1042842" cy="740585"/>
+          </a:xfrm>
+          <a:prstGeom prst="rightArrow">
+            <a:avLst/>
+          </a:prstGeom>
+        </p:spPr>
+        <p:style>
+          <a:lnRef idx="2">
+            <a:schemeClr val="accent1">
+              <a:shade val="50000"/>
+            </a:schemeClr>
+          </a:lnRef>
+          <a:fillRef idx="1">
+            <a:schemeClr val="accent1"/>
+          </a:fillRef>
+          <a:effectRef idx="0">
+            <a:schemeClr val="accent1"/>
+          </a:effectRef>
+          <a:fontRef idx="minor">
+            <a:schemeClr val="lt1"/>
+          </a:fontRef>
+        </p:style>
+        <p:txBody>
+          <a:bodyPr rtlCol="0" anchor="ctr"/>
+          <a:lstStyle/>
+          <a:p>
+            <a:pPr algn="ctr"/>
+            <a:endParaRPr lang="hu-HU"/>
+          </a:p>
+        </p:txBody>
+      </p:sp>
+      <p:pic>
+        <p:nvPicPr>
+          <p:cNvPr id="7" name="Kép 6"/>
+          <p:cNvPicPr>
+            <a:picLocks noChangeAspect="1"/>
+          </p:cNvPicPr>
+          <p:nvPr/>
+        </p:nvPicPr>
+        <p:blipFill>
+          <a:blip r:embed="rId4"/>
+          <a:stretch>
+            <a:fillRect/>
+          </a:stretch>
+        </p:blipFill>
+        <p:spPr>
+          <a:xfrm rot="1078552">
+            <a:off x="4232521" y="3199278"/>
+            <a:ext cx="1110505" cy="806777"/>
+          </a:xfrm>
+          <a:prstGeom prst="rect">
+            <a:avLst/>
+          </a:prstGeom>
+        </p:spPr>
+      </p:pic>
+      <p:pic>
+        <p:nvPicPr>
+          <p:cNvPr id="9" name="Kép 8"/>
+          <p:cNvPicPr>
+            <a:picLocks noChangeAspect="1"/>
+          </p:cNvPicPr>
+          <p:nvPr/>
+        </p:nvPicPr>
+        <p:blipFill>
+          <a:blip r:embed="rId5" cstate="print">
+            <a:extLst>
+              <a:ext uri="{28A0092B-C50C-407E-A947-70E740481C1C}">
+                <a14:useLocalDpi xmlns:a14="http://schemas.microsoft.com/office/drawing/2010/main" val="0"/>
+              </a:ext>
+            </a:extLst>
+          </a:blip>
+          <a:stretch>
+            <a:fillRect/>
+          </a:stretch>
+        </p:blipFill>
+        <p:spPr>
+          <a:xfrm>
+            <a:off x="504434" y="2167921"/>
+            <a:ext cx="3484092" cy="1949882"/>
+          </a:xfrm>
+          <a:prstGeom prst="rect">
+            <a:avLst/>
+          </a:prstGeom>
+          <a:ln>
+            <a:solidFill>
+              <a:schemeClr val="accent1">
+                <a:lumMod val="50000"/>
+              </a:schemeClr>
+            </a:solidFill>
+          </a:ln>
+          <a:effectLst>
+            <a:glow rad="63500">
+              <a:schemeClr val="accent5">
+                <a:satMod val="175000"/>
+                <a:alpha val="40000"/>
+              </a:schemeClr>
+            </a:glow>
+          </a:effectLst>
+        </p:spPr>
+      </p:pic>
+      <p:pic>
+        <p:nvPicPr>
+          <p:cNvPr id="11" name="Kép 10"/>
+          <p:cNvPicPr>
+            <a:picLocks noChangeAspect="1"/>
+          </p:cNvPicPr>
+          <p:nvPr/>
+        </p:nvPicPr>
+        <p:blipFill>
+          <a:blip r:embed="rId6" cstate="print">
+            <a:extLst>
+              <a:ext uri="{28A0092B-C50C-407E-A947-70E740481C1C}">
+                <a14:useLocalDpi xmlns:a14="http://schemas.microsoft.com/office/drawing/2010/main" val="0"/>
+              </a:ext>
+            </a:extLst>
+          </a:blip>
+          <a:stretch>
+            <a:fillRect/>
+          </a:stretch>
+        </p:blipFill>
+        <p:spPr>
+          <a:xfrm>
+            <a:off x="426751" y="4487286"/>
+            <a:ext cx="3561775" cy="2001230"/>
+          </a:xfrm>
+          <a:prstGeom prst="rect">
+            <a:avLst/>
+          </a:prstGeom>
+          <a:ln>
+            <a:solidFill>
+              <a:schemeClr val="accent1">
+                <a:lumMod val="50000"/>
+              </a:schemeClr>
+            </a:solidFill>
+          </a:ln>
+          <a:effectLst>
+            <a:glow rad="63500">
+              <a:schemeClr val="accent5">
+                <a:satMod val="175000"/>
+                <a:alpha val="40000"/>
+              </a:schemeClr>
+            </a:glow>
+          </a:effectLst>
+        </p:spPr>
+      </p:pic>
+      <p:pic>
+        <p:nvPicPr>
+          <p:cNvPr id="12" name="Kép 11"/>
+          <p:cNvPicPr>
+            <a:picLocks noChangeAspect="1"/>
+          </p:cNvPicPr>
+          <p:nvPr/>
+        </p:nvPicPr>
+        <p:blipFill>
+          <a:blip r:embed="rId4"/>
+          <a:stretch>
+            <a:fillRect/>
+          </a:stretch>
+        </p:blipFill>
+        <p:spPr>
+          <a:xfrm rot="1078552">
+            <a:off x="4114445" y="5542744"/>
+            <a:ext cx="1110505" cy="806777"/>
+          </a:xfrm>
+          <a:prstGeom prst="rect">
+            <a:avLst/>
+          </a:prstGeom>
+        </p:spPr>
+      </p:pic>
+      <p:sp>
+        <p:nvSpPr>
+          <p:cNvPr id="13" name="Jobbra nyíl 12"/>
+          <p:cNvSpPr/>
+          <p:nvPr/>
+        </p:nvSpPr>
+        <p:spPr>
+          <a:xfrm rot="20003168">
+            <a:off x="4099161" y="4795620"/>
+            <a:ext cx="1042842" cy="740585"/>
+          </a:xfrm>
+          <a:prstGeom prst="rightArrow">
+            <a:avLst/>
+          </a:prstGeom>
+        </p:spPr>
+        <p:style>
+          <a:lnRef idx="2">
+            <a:schemeClr val="accent1">
+              <a:shade val="50000"/>
+            </a:schemeClr>
+          </a:lnRef>
+          <a:fillRef idx="1">
+            <a:schemeClr val="accent1"/>
+          </a:fillRef>
+          <a:effectRef idx="0">
+            <a:schemeClr val="accent1"/>
+          </a:effectRef>
+          <a:fontRef idx="minor">
+            <a:schemeClr val="lt1"/>
+          </a:fontRef>
+        </p:style>
+        <p:txBody>
+          <a:bodyPr rtlCol="0" anchor="ctr"/>
+          <a:lstStyle/>
+          <a:p>
+            <a:pPr algn="ctr"/>
+            <a:endParaRPr lang="hu-HU"/>
           </a:p>
         </p:txBody>
       </p:sp>
     </p:spTree>
     <p:extLst>
       <p:ext uri="{BB962C8B-B14F-4D97-AF65-F5344CB8AC3E}">
-        <p14:creationId xmlns:p14="http://schemas.microsoft.com/office/powerpoint/2010/main" val="3688369663"/>
+        <p14:creationId xmlns:p14="http://schemas.microsoft.com/office/powerpoint/2010/main" val="1600889108"/>
       </p:ext>
     </p:extLst>
   </p:cSld>

</xml_diff>